<commit_message>
docs(aca): rebuild FactSheet – only fill answer fields, 11pt, no bullets
</commit_message>
<xml_diff>
--- a/aca/H4R2026_FactSheet_ACA.pptx
+++ b/aca/H4R2026_FactSheet_ACA.pptx
@@ -3457,6 +3457,7 @@
           <a:lstStyle/>
           <a:p>
             <a:r>
+              <a:rPr lang="de-DE" i="1" dirty="0" sz="1100"/>
               <a:t>Automatic Contract Analysis</a:t>
             </a:r>
           </a:p>
@@ -3499,7 +3500,12 @@
           <a:lstStyle/>
           <a:p>
             <a:r>
-              <a:t>TheConTextractors</a:t>
+              <a:rPr lang="de-DE" sz="4000" i="1" dirty="0"/>
+              <a:t>Team </a:t>
+            </a:r>
+            <a:r>
+              <a:rPr lang="de-DE" sz="4000" i="1" dirty="0" err="1"/>
+              <a:t>name</a:t>
             </a:r>
             <a:endParaRPr lang="de-DE" sz="4000" i="1" dirty="0"/>
           </a:p>
@@ -3546,32 +3552,97 @@
           <a:p>
             <a:pPr algn="ctr"/>
             <a:r>
+              <a:rPr lang="en-US" b="1" u="sng" dirty="0" sz="1100">
+                <a:solidFill>
+                  <a:srgbClr val="FF0000"/>
+                </a:solidFill>
+                <a:latin typeface="Calibri" panose="020F0502020204030204" pitchFamily="34" charset="0"/>
+                <a:ea typeface="Calibri" panose="020F0502020204030204" pitchFamily="34" charset="0"/>
+                <a:cs typeface="Calibri" panose="020F0502020204030204" pitchFamily="34" charset="0"/>
+              </a:rPr>
               <a:t>Simon Noelle (ÖBB)</a:t>
             </a:r>
+            <a:br>
+              <a:rPr lang="de-DE" u="sng" dirty="0">
+                <a:latin typeface="Calibri" panose="020F0502020204030204" pitchFamily="34" charset="0"/>
+                <a:ea typeface="Calibri" panose="020F0502020204030204" pitchFamily="34" charset="0"/>
+                <a:cs typeface="Calibri" panose="020F0502020204030204" pitchFamily="34" charset="0"/>
+              </a:rPr>
+            </a:br>
+            <a:r>
+              <a:rPr lang="de-DE" sz="1100" i="1" dirty="0">
+                <a:latin typeface="Calibri" panose="020F0502020204030204" pitchFamily="34" charset="0"/>
+                <a:ea typeface="Calibri" panose="020F0502020204030204" pitchFamily="34" charset="0"/>
+                <a:cs typeface="Calibri" panose="020F0502020204030204" pitchFamily="34" charset="0"/>
+              </a:rPr>
+              <a:t>Simon Noelle (ÖBB)</a:t>
+            </a:r>
           </a:p>
           <a:p>
             <a:pPr algn="ctr"/>
             <a:r>
+              <a:rPr lang="de-DE" sz="1100" i="1" dirty="0">
+                <a:latin typeface="Calibri" panose="020F0502020204030204" pitchFamily="34" charset="0"/>
+                <a:ea typeface="Calibri" panose="020F0502020204030204" pitchFamily="34" charset="0"/>
+                <a:cs typeface="Calibri" panose="020F0502020204030204" pitchFamily="34" charset="0"/>
+              </a:rPr>
               <a:t>Simon Engel (ÖBB)</a:t>
             </a:r>
           </a:p>
           <a:p>
             <a:pPr algn="ctr"/>
             <a:r>
+              <a:rPr lang="de-DE" sz="1100" i="1" dirty="0">
+                <a:latin typeface="Calibri" panose="020F0502020204030204" pitchFamily="34" charset="0"/>
+                <a:ea typeface="Calibri" panose="020F0502020204030204" pitchFamily="34" charset="0"/>
+                <a:cs typeface="Calibri" panose="020F0502020204030204" pitchFamily="34" charset="0"/>
+              </a:rPr>
               <a:t>Jens Grote (DB)</a:t>
             </a:r>
           </a:p>
           <a:p>
             <a:pPr algn="ctr"/>
+            <a:r>
+              <a:rPr lang="de-DE" sz="1100" i="1" dirty="0">
+                <a:latin typeface="Calibri" panose="020F0502020204030204" pitchFamily="34" charset="0"/>
+                <a:ea typeface="Calibri" panose="020F0502020204030204" pitchFamily="34" charset="0"/>
+                <a:cs typeface="Calibri" panose="020F0502020204030204" pitchFamily="34" charset="0"/>
+              </a:rPr>
+              <a:t/>
+            </a:r>
           </a:p>
           <a:p>
             <a:pPr algn="ctr"/>
+            <a:r>
+              <a:rPr lang="de-DE" sz="1100" i="1" dirty="0">
+                <a:latin typeface="Calibri" panose="020F0502020204030204" pitchFamily="34" charset="0"/>
+                <a:ea typeface="Calibri" panose="020F0502020204030204" pitchFamily="34" charset="0"/>
+                <a:cs typeface="Calibri" panose="020F0502020204030204" pitchFamily="34" charset="0"/>
+              </a:rPr>
+              <a:t/>
+            </a:r>
           </a:p>
           <a:p>
             <a:pPr algn="ctr"/>
+            <a:r>
+              <a:rPr lang="de-DE" sz="1100" i="1" dirty="0">
+                <a:latin typeface="Calibri" panose="020F0502020204030204" pitchFamily="34" charset="0"/>
+                <a:ea typeface="Calibri" panose="020F0502020204030204" pitchFamily="34" charset="0"/>
+                <a:cs typeface="Calibri" panose="020F0502020204030204" pitchFamily="34" charset="0"/>
+              </a:rPr>
+              <a:t/>
+            </a:r>
           </a:p>
           <a:p>
             <a:pPr algn="ctr"/>
+            <a:r>
+              <a:rPr lang="de-DE" sz="1100" i="1" dirty="0">
+                <a:latin typeface="Calibri" panose="020F0502020204030204" pitchFamily="34" charset="0"/>
+                <a:ea typeface="Calibri" panose="020F0502020204030204" pitchFamily="34" charset="0"/>
+                <a:cs typeface="Calibri" panose="020F0502020204030204" pitchFamily="34" charset="0"/>
+              </a:rPr>
+              <a:t/>
+            </a:r>
           </a:p>
         </p:txBody>
       </p:sp>
@@ -3776,10 +3847,39 @@
           </a:lstStyle>
           <a:p>
             <a:r>
+              <a:rPr lang="de-DE" sz="1100" b="1" u="sng" dirty="0">
+                <a:solidFill>
+                  <a:srgbClr val="FF0000"/>
+                </a:solidFill>
+              </a:rPr>
               <a:t>SBB Infrastruktur</a:t>
             </a:r>
-          </a:p>
-          <a:p/>
+            <a:r>
+              <a:rPr lang="de-DE" sz="1100" i="1" u="sng" dirty="0"/>
+              <a:t>SBB Infrastruktur</a:t>
+            </a:r>
+            <a:r>
+              <a:rPr lang="de-DE" sz="1100" b="1" u="sng" dirty="0">
+                <a:solidFill>
+                  <a:srgbClr val="FF0000"/>
+                </a:solidFill>
+              </a:rPr>
+              <a:t>SBB Infrastruktur</a:t>
+            </a:r>
+          </a:p>
+          <a:p>
+            <a:r>
+              <a:rPr lang="de-DE" sz="1100" i="1" dirty="0"/>
+              <a:t/>
+            </a:r>
+            <a:br>
+              <a:rPr lang="de-DE" sz="1400" i="1" dirty="0"/>
+            </a:br>
+            <a:r>
+              <a:rPr lang="de-DE" sz="1100" i="1" dirty="0"/>
+              <a:t/>
+            </a:r>
+          </a:p>
         </p:txBody>
       </p:sp>
     </p:spTree>
@@ -3841,7 +3941,42 @@
           <a:lstStyle/>
           <a:p>
             <a:r>
-              <a:t>SBB manages 10,000+ infrastructure contracts from 150 years (crossing structures, financing agreements, station contracts). Contracts exist as PDFs – from handwritten documents (1926) to current agreements. Contract data must be manually captured in SAP/ContrAct: 13 fields + cost allocation. This is time-consuming, error-prone, and does not scale.</a:t>
+              <a:rPr lang="en-US" sz="1400" b="1" i="0" dirty="0">
+                <a:solidFill>
+                  <a:srgbClr val="0F172A"/>
+                </a:solidFill>
+                <a:effectLst/>
+              </a:rPr>
+              <a:t>Description of the Challenge</a:t>
+            </a:r>
+            <a:br>
+              <a:rPr lang="en-US" sz="1400" dirty="0"/>
+            </a:br>
+            <a:r>
+              <a:rPr lang="en-US" sz="1050" b="0" i="0" dirty="0">
+                <a:solidFill>
+                  <a:srgbClr val="334155"/>
+                </a:solidFill>
+                <a:effectLst/>
+              </a:rPr>
+              <a:t>What is the problem/idea? What is the current status? </a:t>
+            </a:r>
+            <a:br>
+              <a:rPr lang="en-US" sz="1050" b="0" i="0" dirty="0">
+                <a:solidFill>
+                  <a:srgbClr val="334155"/>
+                </a:solidFill>
+                <a:effectLst/>
+              </a:rPr>
+            </a:br>
+            <a:r>
+              <a:rPr lang="en-US" sz="1050" b="0" i="0" dirty="0">
+                <a:solidFill>
+                  <a:srgbClr val="334155"/>
+                </a:solidFill>
+                <a:effectLst/>
+              </a:rPr>
+              <a:t>Focus on important/central points.</a:t>
             </a:r>
             <a:endParaRPr lang="de-DE" sz="1050" dirty="0"/>
           </a:p>
@@ -3885,20 +4020,20 @@
               <a:buNone/>
             </a:pPr>
             <a:r>
+              <a:rPr lang="de-DE" sz="1100" dirty="0"/>
+              <a:t>SBB manages 10,000+ infrastructure contracts from 150 years (crossing structures, financing agreements, station contracts). Contracts exist as PDFs – from handwritten documents (1926) to current agreements. Contract data must be manually captured in SAP/ContrAct: 13 fields + cost allocation. This is time-consuming, error-prone, and does not scale.</a:t>
+            </a:r>
+            <a:r>
+              <a:rPr lang="de-DE" sz="1050" dirty="0" err="1"/>
+              <a:t/>
+            </a:r>
+            <a:r>
               <a:rPr lang="de-DE" sz="1050" dirty="0"/>
-              <a:t>Field </a:t>
+              <a:t/>
             </a:r>
             <a:r>
               <a:rPr lang="de-DE" sz="1050" dirty="0" err="1"/>
-              <a:t>for</a:t>
-            </a:r>
-            <a:r>
-              <a:rPr lang="de-DE" sz="1050" dirty="0"/>
-              <a:t> </a:t>
-            </a:r>
-            <a:r>
-              <a:rPr lang="de-DE" sz="1050" dirty="0" err="1"/>
-              <a:t>Answers</a:t>
+              <a:t/>
             </a:r>
             <a:endParaRPr lang="de-DE" sz="1050" dirty="0"/>
           </a:p>
@@ -3952,7 +4087,41 @@
           </a:lstStyle>
           <a:p>
             <a:r>
-              <a:t>AI-powered extraction pipeline: PDF → text extraction (markitdown) → LLM structured extraction → validated JSON. Each field includes confidence level (eindeutig/abgeleitet/fehlend) and source reference. Validated against a machine-readable contract taxonomy schema.</a:t>
+              <a:rPr lang="en-US" sz="1400" b="1" i="0" dirty="0">
+                <a:solidFill>
+                  <a:srgbClr val="0F172A"/>
+                </a:solidFill>
+                <a:effectLst/>
+              </a:rPr>
+              <a:t>Description of the Solution or Idea</a:t>
+            </a:r>
+            <a:br>
+              <a:rPr lang="en-US" sz="1400" dirty="0"/>
+            </a:br>
+            <a:r>
+              <a:rPr lang="en-US" sz="1050" b="0" i="0" dirty="0">
+                <a:solidFill>
+                  <a:srgbClr val="334155"/>
+                </a:solidFill>
+                <a:effectLst/>
+              </a:rPr>
+              <a:t>What are the key features of the solution?</a:t>
+            </a:r>
+            <a:br>
+              <a:rPr lang="en-US" sz="1050" b="0" dirty="0">
+                <a:solidFill>
+                  <a:srgbClr val="334155"/>
+                </a:solidFill>
+              </a:rPr>
+            </a:br>
+            <a:r>
+              <a:rPr lang="en-US" sz="1050" b="0" i="0" dirty="0">
+                <a:solidFill>
+                  <a:srgbClr val="334155"/>
+                </a:solidFill>
+                <a:effectLst/>
+              </a:rPr>
+              <a:t>Focus on important/central points.</a:t>
             </a:r>
             <a:endParaRPr lang="de-DE" sz="1050" dirty="0"/>
           </a:p>
@@ -4160,20 +4329,20 @@
               <a:buNone/>
             </a:pPr>
             <a:r>
+              <a:rPr lang="de-DE" sz="1100" dirty="0"/>
+              <a:t>AI-powered extraction pipeline: PDF → text extraction (markitdown) → LLM structured extraction → validated JSON. Each field includes confidence level (eindeutig/abgeleitet/fehlend) and source reference. Validated against a machine-readable contract taxonomy schema.</a:t>
+            </a:r>
+            <a:r>
+              <a:rPr lang="de-DE" sz="1050" dirty="0" err="1"/>
+              <a:t/>
+            </a:r>
+            <a:r>
               <a:rPr lang="de-DE" sz="1050" dirty="0"/>
-              <a:t>Field </a:t>
+              <a:t/>
             </a:r>
             <a:r>
               <a:rPr lang="de-DE" sz="1050" dirty="0" err="1"/>
-              <a:t>for</a:t>
-            </a:r>
-            <a:r>
-              <a:rPr lang="de-DE" sz="1050" dirty="0"/>
-              <a:t> </a:t>
-            </a:r>
-            <a:r>
-              <a:rPr lang="de-DE" sz="1050" dirty="0" err="1"/>
-              <a:t>Answers</a:t>
+              <a:t/>
             </a:r>
             <a:endParaRPr lang="de-DE" sz="1050" dirty="0"/>
           </a:p>
@@ -4432,15 +4601,22 @@
           </a:lstStyle>
           <a:p>
             <a:r>
+              <a:rPr lang="de-DE" sz="1100" dirty="0"/>
               <a:t>GitHub Repository: https://github.com/OpenRail-Playground/A38</a:t>
             </a:r>
           </a:p>
           <a:p>
             <a:r>
-              <a:t>Demo: Live PDF → validated JSON extraction</a:t>
-            </a:r>
-          </a:p>
-          <a:p/>
+              <a:rPr lang="de-DE" sz="1100" dirty="0"/>
+              <a:t>Demo: Live PDF to validated JSON extraction</a:t>
+            </a:r>
+          </a:p>
+          <a:p>
+            <a:r>
+              <a:rPr lang="de-DE" sz="1100" dirty="0"/>
+              <a:t>Further Links: -</a:t>
+            </a:r>
+          </a:p>
         </p:txBody>
       </p:sp>
     </p:spTree>
@@ -4508,7 +4684,20 @@
           <a:lstStyle/>
           <a:p>
             <a:r>
-              <a:t>SBB Infrastruktur (contract management), asset managers, finance departments, legal teams. Applicable to DB, ÖBB and other railways.</a:t>
+              <a:rPr lang="de-DE" sz="1100" dirty="0"/>
+              <a:t>SBB Infrastruktur (contract management), asset managers, finance departments, legal teams. Applicable to DB, OeBB and other railways with similar contract portfolios.</a:t>
+            </a:r>
+            <a:r>
+              <a:rPr lang="de-DE" sz="1050" dirty="0" err="1"/>
+              <a:t/>
+            </a:r>
+            <a:r>
+              <a:rPr lang="de-DE" sz="1050" dirty="0"/>
+              <a:t/>
+            </a:r>
+            <a:r>
+              <a:rPr lang="de-DE" sz="1050" dirty="0" err="1"/>
+              <a:t/>
             </a:r>
             <a:endParaRPr lang="de-DE" sz="1050" dirty="0"/>
           </a:p>
@@ -4781,7 +4970,20 @@
           </a:lstStyle>
           <a:p>
             <a:r>
+              <a:rPr lang="de-DE" sz="1100" dirty="0"/>
               <a:t>Manual data entry into SAP/ContrAct. No production-grade automated solution exists.</a:t>
+            </a:r>
+            <a:r>
+              <a:rPr lang="de-DE" sz="1050" dirty="0" err="1"/>
+              <a:t/>
+            </a:r>
+            <a:r>
+              <a:rPr lang="de-DE" sz="1050" dirty="0"/>
+              <a:t/>
+            </a:r>
+            <a:r>
+              <a:rPr lang="de-DE" sz="1050" dirty="0" err="1"/>
+              <a:t/>
             </a:r>
             <a:endParaRPr lang="de-DE" sz="1050" dirty="0"/>
           </a:p>
@@ -5054,7 +5256,20 @@
           </a:lstStyle>
           <a:p>
             <a:r>
-              <a:t>10,000+ contracts × 30-60 min manual effort. Automated extraction reduces to minutes with human-in-the-loop for edge cases. Enables proactive contract management.</a:t>
+              <a:rPr lang="de-DE" sz="1100" dirty="0"/>
+              <a:t>10,000+ contracts x 30-60 min manual effort. Automated extraction reduces to minutes with human-in-the-loop for edge cases. Enables proactive contract management (expiry alerts, missing successors).</a:t>
+            </a:r>
+            <a:r>
+              <a:rPr lang="de-DE" sz="1050" dirty="0" err="1"/>
+              <a:t/>
+            </a:r>
+            <a:r>
+              <a:rPr lang="de-DE" sz="1050" dirty="0"/>
+              <a:t/>
+            </a:r>
+            <a:r>
+              <a:rPr lang="de-DE" sz="1050" dirty="0" err="1"/>
+              <a:t/>
             </a:r>
             <a:endParaRPr lang="de-DE" sz="1050" dirty="0"/>
           </a:p>
@@ -5324,7 +5539,20 @@
           </a:lstStyle>
           <a:p>
             <a:r>
-              <a:t>Pure OCR without LLM (cannot handle semantic extraction). Unvalidated LLM output without taxonomy (not auditable). Fully manual (does not scale).</a:t>
+              <a:rPr lang="de-DE" sz="1100" dirty="0"/>
+              <a:t>Pure OCR without LLM (cannot handle semantic extraction from complex legal text). Unvalidated LLM output without taxonomy schema (not auditable). Fully manual approach (does not scale).</a:t>
+            </a:r>
+            <a:r>
+              <a:rPr lang="de-DE" sz="1050" dirty="0" err="1"/>
+              <a:t/>
+            </a:r>
+            <a:r>
+              <a:rPr lang="de-DE" sz="1050" dirty="0"/>
+              <a:t/>
+            </a:r>
+            <a:r>
+              <a:rPr lang="de-DE" sz="1050" dirty="0" err="1"/>
+              <a:t/>
             </a:r>
             <a:endParaRPr lang="de-DE" sz="1050" dirty="0"/>
           </a:p>
@@ -5603,7 +5831,20 @@
           </a:lstStyle>
           <a:p>
             <a:r>
-              <a:t>Better contract oversight reduces missed obligations. Cross-company interoperability. Foundation for automated compliance (bridge to OSCAL4Rail).</a:t>
+              <a:rPr lang="de-DE" sz="1100" dirty="0"/>
+              <a:t>Better contract oversight reduces risk of missed obligations. Enables cross-company contract interoperability. Foundation for automated compliance checking (bridge to OSCAL4Rail).</a:t>
+            </a:r>
+            <a:r>
+              <a:rPr lang="de-DE" sz="1050" dirty="0" err="1"/>
+              <a:t/>
+            </a:r>
+            <a:r>
+              <a:rPr lang="de-DE" sz="1050" dirty="0"/>
+              <a:t/>
+            </a:r>
+            <a:r>
+              <a:rPr lang="de-DE" sz="1050" dirty="0" err="1"/>
+              <a:t/>
             </a:r>
             <a:endParaRPr lang="de-DE" sz="1050" dirty="0"/>
           </a:p>
@@ -5885,7 +6126,20 @@
           </a:lstStyle>
           <a:p>
             <a:r>
-              <a:t>Older contracts (pre-1990, handwritten): lower extraction quality. Multi-language (DE/FR/IT). LLM cost for batch. Data privacy.</a:t>
+              <a:rPr lang="de-DE" sz="1100" dirty="0"/>
+              <a:t>Older contracts (pre-1990, handwritten) have lower extraction quality. Multi-language support (DE/FR/IT) needs tuning. LLM availability and cost for batch processing. Data privacy for contract parties.</a:t>
+            </a:r>
+            <a:r>
+              <a:rPr lang="de-DE" sz="1050" dirty="0" err="1"/>
+              <a:t/>
+            </a:r>
+            <a:r>
+              <a:rPr lang="de-DE" sz="1050" dirty="0"/>
+              <a:t/>
+            </a:r>
+            <a:r>
+              <a:rPr lang="de-DE" sz="1050" dirty="0" err="1"/>
+              <a:t/>
             </a:r>
             <a:endParaRPr lang="de-DE" sz="1050" dirty="0"/>
           </a:p>
@@ -6167,7 +6421,20 @@
           </a:lstStyle>
           <a:p>
             <a:r>
-              <a:t>LLM extraction: mature (Claude Sonnet 4). PDF parsing (markitdown): production-ready. Taxonomy: prototype. JSON Schema validation: standard.</a:t>
+              <a:rPr lang="de-DE" sz="1100" dirty="0"/>
+              <a:t>LLM extraction: mature (Claude Sonnet 4). PDF parsing (markitdown): production-ready. JSON Schema validation: standard. Taxonomy model: prototype (Hack4Rail 2026).</a:t>
+            </a:r>
+            <a:r>
+              <a:rPr lang="de-DE" sz="1050" dirty="0" err="1"/>
+              <a:t/>
+            </a:r>
+            <a:r>
+              <a:rPr lang="de-DE" sz="1050" dirty="0"/>
+              <a:t/>
+            </a:r>
+            <a:r>
+              <a:rPr lang="de-DE" sz="1050" dirty="0" err="1"/>
+              <a:t/>
             </a:r>
             <a:endParaRPr lang="de-DE" sz="1050" dirty="0"/>
           </a:p>
@@ -6445,7 +6712,20 @@
           </a:lstStyle>
           <a:p>
             <a:r>
-              <a:t>Ready-to-use prototype delivered. Challenge owners can continue next week. Complete contract classification within next months.</a:t>
+              <a:rPr lang="de-DE" sz="1100" dirty="0"/>
+              <a:t>May depend on the railway company.</a:t>
+            </a:r>
+            <a:r>
+              <a:rPr lang="de-DE" sz="1050" dirty="0" err="1"/>
+              <a:t/>
+            </a:r>
+            <a:r>
+              <a:rPr lang="de-DE" sz="1050" dirty="0"/>
+              <a:t/>
+            </a:r>
+            <a:r>
+              <a:rPr lang="de-DE" sz="1050" dirty="0" err="1"/>
+              <a:t/>
             </a:r>
             <a:endParaRPr lang="de-DE" sz="1050" dirty="0"/>
           </a:p>

</xml_diff>

<commit_message>
docs: manual refinements to both FactSheets
</commit_message>
<xml_diff>
--- a/aca/H4R2026_FactSheet_ACA.pptx
+++ b/aca/H4R2026_FactSheet_ACA.pptx
@@ -5,7 +5,7 @@
     <p:sldMasterId id="2147483648" r:id="rId4"/>
   </p:sldMasterIdLst>
   <p:sldIdLst>
-    <p:sldId id="256" r:id="rId5"/>
+    <p:sldId id="259" r:id="rId5"/>
     <p:sldId id="257" r:id="rId6"/>
     <p:sldId id="258" r:id="rId7"/>
   </p:sldIdLst>
@@ -269,7 +269,7 @@
           <a:p>
             <a:fld id="{73E09B6B-B446-416C-B509-27F8143F0A75}" type="datetimeFigureOut">
               <a:rPr lang="de-DE" smtClean="0"/>
-              <a:t>17.06.2026</a:t>
+              <a:t>24.06.26</a:t>
             </a:fld>
             <a:endParaRPr lang="de-DE"/>
           </a:p>
@@ -323,7 +323,7 @@
           <a:p>
             <a:fld id="{47371D93-8784-4C02-8B2C-86355AB378F9}" type="slidenum">
               <a:rPr lang="de-DE" smtClean="0"/>
-              <a:t>‹Nr.›</a:t>
+              <a:t>‹#›</a:t>
             </a:fld>
             <a:endParaRPr lang="de-DE"/>
           </a:p>
@@ -467,7 +467,7 @@
           <a:p>
             <a:fld id="{73E09B6B-B446-416C-B509-27F8143F0A75}" type="datetimeFigureOut">
               <a:rPr lang="de-DE" smtClean="0"/>
-              <a:t>17.06.2026</a:t>
+              <a:t>24.06.26</a:t>
             </a:fld>
             <a:endParaRPr lang="de-DE"/>
           </a:p>
@@ -521,7 +521,7 @@
           <a:p>
             <a:fld id="{47371D93-8784-4C02-8B2C-86355AB378F9}" type="slidenum">
               <a:rPr lang="de-DE" smtClean="0"/>
-              <a:t>‹Nr.›</a:t>
+              <a:t>‹#›</a:t>
             </a:fld>
             <a:endParaRPr lang="de-DE"/>
           </a:p>
@@ -675,7 +675,7 @@
           <a:p>
             <a:fld id="{73E09B6B-B446-416C-B509-27F8143F0A75}" type="datetimeFigureOut">
               <a:rPr lang="de-DE" smtClean="0"/>
-              <a:t>17.06.2026</a:t>
+              <a:t>24.06.26</a:t>
             </a:fld>
             <a:endParaRPr lang="de-DE"/>
           </a:p>
@@ -729,7 +729,7 @@
           <a:p>
             <a:fld id="{47371D93-8784-4C02-8B2C-86355AB378F9}" type="slidenum">
               <a:rPr lang="de-DE" smtClean="0"/>
-              <a:t>‹Nr.›</a:t>
+              <a:t>‹#›</a:t>
             </a:fld>
             <a:endParaRPr lang="de-DE"/>
           </a:p>
@@ -873,7 +873,7 @@
           <a:p>
             <a:fld id="{73E09B6B-B446-416C-B509-27F8143F0A75}" type="datetimeFigureOut">
               <a:rPr lang="de-DE" smtClean="0"/>
-              <a:t>17.06.2026</a:t>
+              <a:t>24.06.26</a:t>
             </a:fld>
             <a:endParaRPr lang="de-DE"/>
           </a:p>
@@ -927,7 +927,7 @@
           <a:p>
             <a:fld id="{47371D93-8784-4C02-8B2C-86355AB378F9}" type="slidenum">
               <a:rPr lang="de-DE" smtClean="0"/>
-              <a:t>‹Nr.›</a:t>
+              <a:t>‹#›</a:t>
             </a:fld>
             <a:endParaRPr lang="de-DE"/>
           </a:p>
@@ -1148,7 +1148,7 @@
           <a:p>
             <a:fld id="{73E09B6B-B446-416C-B509-27F8143F0A75}" type="datetimeFigureOut">
               <a:rPr lang="de-DE" smtClean="0"/>
-              <a:t>17.06.2026</a:t>
+              <a:t>24.06.26</a:t>
             </a:fld>
             <a:endParaRPr lang="de-DE"/>
           </a:p>
@@ -1202,7 +1202,7 @@
           <a:p>
             <a:fld id="{47371D93-8784-4C02-8B2C-86355AB378F9}" type="slidenum">
               <a:rPr lang="de-DE" smtClean="0"/>
-              <a:t>‹Nr.›</a:t>
+              <a:t>‹#›</a:t>
             </a:fld>
             <a:endParaRPr lang="de-DE"/>
           </a:p>
@@ -1413,7 +1413,7 @@
           <a:p>
             <a:fld id="{73E09B6B-B446-416C-B509-27F8143F0A75}" type="datetimeFigureOut">
               <a:rPr lang="de-DE" smtClean="0"/>
-              <a:t>17.06.2026</a:t>
+              <a:t>24.06.26</a:t>
             </a:fld>
             <a:endParaRPr lang="de-DE"/>
           </a:p>
@@ -1467,7 +1467,7 @@
           <a:p>
             <a:fld id="{47371D93-8784-4C02-8B2C-86355AB378F9}" type="slidenum">
               <a:rPr lang="de-DE" smtClean="0"/>
-              <a:t>‹Nr.›</a:t>
+              <a:t>‹#›</a:t>
             </a:fld>
             <a:endParaRPr lang="de-DE"/>
           </a:p>
@@ -1825,7 +1825,7 @@
           <a:p>
             <a:fld id="{73E09B6B-B446-416C-B509-27F8143F0A75}" type="datetimeFigureOut">
               <a:rPr lang="de-DE" smtClean="0"/>
-              <a:t>17.06.2026</a:t>
+              <a:t>24.06.26</a:t>
             </a:fld>
             <a:endParaRPr lang="de-DE"/>
           </a:p>
@@ -1879,7 +1879,7 @@
           <a:p>
             <a:fld id="{47371D93-8784-4C02-8B2C-86355AB378F9}" type="slidenum">
               <a:rPr lang="de-DE" smtClean="0"/>
-              <a:t>‹Nr.›</a:t>
+              <a:t>‹#›</a:t>
             </a:fld>
             <a:endParaRPr lang="de-DE"/>
           </a:p>
@@ -1966,7 +1966,7 @@
           <a:p>
             <a:fld id="{73E09B6B-B446-416C-B509-27F8143F0A75}" type="datetimeFigureOut">
               <a:rPr lang="de-DE" smtClean="0"/>
-              <a:t>17.06.2026</a:t>
+              <a:t>24.06.26</a:t>
             </a:fld>
             <a:endParaRPr lang="de-DE"/>
           </a:p>
@@ -2020,7 +2020,7 @@
           <a:p>
             <a:fld id="{47371D93-8784-4C02-8B2C-86355AB378F9}" type="slidenum">
               <a:rPr lang="de-DE" smtClean="0"/>
-              <a:t>‹Nr.›</a:t>
+              <a:t>‹#›</a:t>
             </a:fld>
             <a:endParaRPr lang="de-DE"/>
           </a:p>
@@ -2079,7 +2079,7 @@
           <a:p>
             <a:fld id="{73E09B6B-B446-416C-B509-27F8143F0A75}" type="datetimeFigureOut">
               <a:rPr lang="de-DE" smtClean="0"/>
-              <a:t>17.06.2026</a:t>
+              <a:t>24.06.26</a:t>
             </a:fld>
             <a:endParaRPr lang="de-DE"/>
           </a:p>
@@ -2133,7 +2133,7 @@
           <a:p>
             <a:fld id="{47371D93-8784-4C02-8B2C-86355AB378F9}" type="slidenum">
               <a:rPr lang="de-DE" smtClean="0"/>
-              <a:t>‹Nr.›</a:t>
+              <a:t>‹#›</a:t>
             </a:fld>
             <a:endParaRPr lang="de-DE"/>
           </a:p>
@@ -2390,7 +2390,7 @@
           <a:p>
             <a:fld id="{73E09B6B-B446-416C-B509-27F8143F0A75}" type="datetimeFigureOut">
               <a:rPr lang="de-DE" smtClean="0"/>
-              <a:t>17.06.2026</a:t>
+              <a:t>24.06.26</a:t>
             </a:fld>
             <a:endParaRPr lang="de-DE"/>
           </a:p>
@@ -2444,7 +2444,7 @@
           <a:p>
             <a:fld id="{47371D93-8784-4C02-8B2C-86355AB378F9}" type="slidenum">
               <a:rPr lang="de-DE" smtClean="0"/>
-              <a:t>‹Nr.›</a:t>
+              <a:t>‹#›</a:t>
             </a:fld>
             <a:endParaRPr lang="de-DE"/>
           </a:p>
@@ -2678,7 +2678,7 @@
           <a:p>
             <a:fld id="{73E09B6B-B446-416C-B509-27F8143F0A75}" type="datetimeFigureOut">
               <a:rPr lang="de-DE" smtClean="0"/>
-              <a:t>17.06.2026</a:t>
+              <a:t>24.06.26</a:t>
             </a:fld>
             <a:endParaRPr lang="de-DE"/>
           </a:p>
@@ -2732,7 +2732,7 @@
           <a:p>
             <a:fld id="{47371D93-8784-4C02-8B2C-86355AB378F9}" type="slidenum">
               <a:rPr lang="de-DE" smtClean="0"/>
-              <a:t>‹Nr.›</a:t>
+              <a:t>‹#›</a:t>
             </a:fld>
             <a:endParaRPr lang="de-DE"/>
           </a:p>
@@ -2919,7 +2919,7 @@
           <a:p>
             <a:fld id="{73E09B6B-B446-416C-B509-27F8143F0A75}" type="datetimeFigureOut">
               <a:rPr lang="de-DE" smtClean="0"/>
-              <a:t>17.06.2026</a:t>
+              <a:t>24.06.26</a:t>
             </a:fld>
             <a:endParaRPr lang="de-DE"/>
           </a:p>
@@ -3009,7 +3009,7 @@
           <a:p>
             <a:fld id="{47371D93-8784-4C02-8B2C-86355AB378F9}" type="slidenum">
               <a:rPr lang="de-DE" smtClean="0"/>
-              <a:t>‹Nr.›</a:t>
+              <a:t>‹#›</a:t>
             </a:fld>
             <a:endParaRPr lang="de-DE"/>
           </a:p>
@@ -3457,8 +3457,20 @@
           <a:lstStyle/>
           <a:p>
             <a:r>
-              <a:rPr lang="de-DE" i="1" dirty="0" sz="1100"/>
-              <a:t>Automatic Contract Analysis</a:t>
+              <a:rPr lang="de-DE" i="1" dirty="0" err="1"/>
+              <a:t>Automatic</a:t>
+            </a:r>
+            <a:r>
+              <a:rPr lang="de-DE" i="1" dirty="0"/>
+              <a:t> </a:t>
+            </a:r>
+            <a:r>
+              <a:rPr lang="de-DE" i="1" dirty="0" err="1"/>
+              <a:t>Contract</a:t>
+            </a:r>
+            <a:r>
+              <a:rPr lang="de-DE" i="1" dirty="0"/>
+              <a:t> Analysis</a:t>
             </a:r>
           </a:p>
         </p:txBody>
@@ -3501,12 +3513,15 @@
           <a:p>
             <a:r>
               <a:rPr lang="de-DE" sz="4000" i="1" dirty="0"/>
-              <a:t>Team </a:t>
+              <a:t>The </a:t>
             </a:r>
             <a:r>
               <a:rPr lang="de-DE" sz="4000" i="1" dirty="0" err="1"/>
-              <a:t>name</a:t>
-            </a:r>
+              <a:t>Contextractors</a:t>
+            </a:r>
+            <a:endParaRPr lang="de-DE" sz="4000" i="1" dirty="0"/>
+          </a:p>
+          <a:p>
             <a:endParaRPr lang="de-DE" sz="4000" i="1" dirty="0"/>
           </a:p>
           <a:p>
@@ -3528,8 +3543,8 @@
         </p:nvSpPr>
         <p:spPr>
           <a:xfrm>
-            <a:off x="2382328" y="4589479"/>
-            <a:ext cx="7427343" cy="1877437"/>
+            <a:off x="2382328" y="5020366"/>
+            <a:ext cx="7427343" cy="1015663"/>
           </a:xfrm>
           <a:prstGeom prst="rect">
             <a:avLst/>
@@ -3552,7 +3567,7 @@
           <a:p>
             <a:pPr algn="ctr"/>
             <a:r>
-              <a:rPr lang="en-US" b="1" u="sng" dirty="0" sz="1100">
+              <a:rPr lang="en-US" b="1" u="sng" dirty="0">
                 <a:solidFill>
                   <a:srgbClr val="FF0000"/>
                 </a:solidFill>
@@ -3560,7 +3575,7 @@
                 <a:ea typeface="Calibri" panose="020F0502020204030204" pitchFamily="34" charset="0"/>
                 <a:cs typeface="Calibri" panose="020F0502020204030204" pitchFamily="34" charset="0"/>
               </a:rPr>
-              <a:t>Simon Noelle (ÖBB)</a:t>
+              <a:t>Team Member (max. 7)</a:t>
             </a:r>
             <a:br>
               <a:rPr lang="de-DE" u="sng" dirty="0">
@@ -3570,79 +3585,44 @@
               </a:rPr>
             </a:br>
             <a:r>
-              <a:rPr lang="de-DE" sz="1100" i="1" dirty="0">
+              <a:rPr lang="de-DE" sz="1400" i="1" dirty="0">
                 <a:latin typeface="Calibri" panose="020F0502020204030204" pitchFamily="34" charset="0"/>
                 <a:ea typeface="Calibri" panose="020F0502020204030204" pitchFamily="34" charset="0"/>
                 <a:cs typeface="Calibri" panose="020F0502020204030204" pitchFamily="34" charset="0"/>
+                <a:hlinkClick r:id="rId2"/>
               </a:rPr>
-              <a:t>Simon Noelle (ÖBB)</a:t>
-            </a:r>
+              <a:t>jens.grote@deutschebahn.com</a:t>
+            </a:r>
+            <a:endParaRPr lang="de-DE" sz="1400" i="1" dirty="0">
+              <a:latin typeface="Calibri" panose="020F0502020204030204" pitchFamily="34" charset="0"/>
+              <a:ea typeface="Calibri" panose="020F0502020204030204" pitchFamily="34" charset="0"/>
+              <a:cs typeface="Calibri" panose="020F0502020204030204" pitchFamily="34" charset="0"/>
+            </a:endParaRPr>
           </a:p>
           <a:p>
             <a:pPr algn="ctr"/>
             <a:r>
-              <a:rPr lang="de-DE" sz="1100" i="1" dirty="0">
+              <a:rPr lang="de-DE" sz="1400" i="1" dirty="0">
                 <a:latin typeface="Calibri" panose="020F0502020204030204" pitchFamily="34" charset="0"/>
                 <a:ea typeface="Calibri" panose="020F0502020204030204" pitchFamily="34" charset="0"/>
                 <a:cs typeface="Calibri" panose="020F0502020204030204" pitchFamily="34" charset="0"/>
+                <a:hlinkClick r:id="rId3"/>
               </a:rPr>
-              <a:t>Simon Engel (ÖBB)</a:t>
-            </a:r>
+              <a:t>Jonathan.wolf@deutschebahn.com</a:t>
+            </a:r>
+            <a:endParaRPr lang="de-DE" sz="1400" i="1" dirty="0">
+              <a:latin typeface="Calibri" panose="020F0502020204030204" pitchFamily="34" charset="0"/>
+              <a:ea typeface="Calibri" panose="020F0502020204030204" pitchFamily="34" charset="0"/>
+              <a:cs typeface="Calibri" panose="020F0502020204030204" pitchFamily="34" charset="0"/>
+            </a:endParaRPr>
           </a:p>
           <a:p>
             <a:pPr algn="ctr"/>
-            <a:r>
-              <a:rPr lang="de-DE" sz="1100" i="1" dirty="0">
-                <a:latin typeface="Calibri" panose="020F0502020204030204" pitchFamily="34" charset="0"/>
-                <a:ea typeface="Calibri" panose="020F0502020204030204" pitchFamily="34" charset="0"/>
-                <a:cs typeface="Calibri" panose="020F0502020204030204" pitchFamily="34" charset="0"/>
-              </a:rPr>
-              <a:t>Jens Grote (DB)</a:t>
-            </a:r>
-          </a:p>
-          <a:p>
-            <a:pPr algn="ctr"/>
-            <a:r>
-              <a:rPr lang="de-DE" sz="1100" i="1" dirty="0">
-                <a:latin typeface="Calibri" panose="020F0502020204030204" pitchFamily="34" charset="0"/>
-                <a:ea typeface="Calibri" panose="020F0502020204030204" pitchFamily="34" charset="0"/>
-                <a:cs typeface="Calibri" panose="020F0502020204030204" pitchFamily="34" charset="0"/>
-              </a:rPr>
-              <a:t/>
-            </a:r>
-          </a:p>
-          <a:p>
-            <a:pPr algn="ctr"/>
-            <a:r>
-              <a:rPr lang="de-DE" sz="1100" i="1" dirty="0">
-                <a:latin typeface="Calibri" panose="020F0502020204030204" pitchFamily="34" charset="0"/>
-                <a:ea typeface="Calibri" panose="020F0502020204030204" pitchFamily="34" charset="0"/>
-                <a:cs typeface="Calibri" panose="020F0502020204030204" pitchFamily="34" charset="0"/>
-              </a:rPr>
-              <a:t/>
-            </a:r>
-          </a:p>
-          <a:p>
-            <a:pPr algn="ctr"/>
-            <a:r>
-              <a:rPr lang="de-DE" sz="1100" i="1" dirty="0">
-                <a:latin typeface="Calibri" panose="020F0502020204030204" pitchFamily="34" charset="0"/>
-                <a:ea typeface="Calibri" panose="020F0502020204030204" pitchFamily="34" charset="0"/>
-                <a:cs typeface="Calibri" panose="020F0502020204030204" pitchFamily="34" charset="0"/>
-              </a:rPr>
-              <a:t/>
-            </a:r>
-          </a:p>
-          <a:p>
-            <a:pPr algn="ctr"/>
-            <a:r>
-              <a:rPr lang="de-DE" sz="1100" i="1" dirty="0">
-                <a:latin typeface="Calibri" panose="020F0502020204030204" pitchFamily="34" charset="0"/>
-                <a:ea typeface="Calibri" panose="020F0502020204030204" pitchFamily="34" charset="0"/>
-                <a:cs typeface="Calibri" panose="020F0502020204030204" pitchFamily="34" charset="0"/>
-              </a:rPr>
-              <a:t/>
-            </a:r>
+            <a:endParaRPr lang="de-DE" sz="1400" i="1" dirty="0">
+              <a:latin typeface="Calibri" panose="020F0502020204030204" pitchFamily="34" charset="0"/>
+              <a:ea typeface="Calibri" panose="020F0502020204030204" pitchFamily="34" charset="0"/>
+              <a:cs typeface="Calibri" panose="020F0502020204030204" pitchFamily="34" charset="0"/>
+            </a:endParaRPr>
           </a:p>
         </p:txBody>
       </p:sp>
@@ -3679,7 +3659,7 @@
         </p:spPr>
         <p:txBody>
           <a:bodyPr vert="horz" lIns="91440" tIns="45720" rIns="91440" bIns="45720" rtlCol="0" anchor="ctr">
-            <a:normAutofit lnSpcReduction="10000"/>
+            <a:normAutofit fontScale="85000" lnSpcReduction="20000"/>
           </a:bodyPr>
           <a:lstStyle>
             <a:lvl1pPr marL="0" indent="0" algn="ctr" defTabSz="914400" rtl="0" eaLnBrk="1" latinLnBrk="0" hangingPunct="1">
@@ -3847,45 +3827,50 @@
           </a:lstStyle>
           <a:p>
             <a:r>
-              <a:rPr lang="de-DE" sz="1100" b="1" u="sng" dirty="0">
+              <a:rPr lang="de-DE" sz="1800" b="1" u="sng" dirty="0">
                 <a:solidFill>
                   <a:srgbClr val="FF0000"/>
                 </a:solidFill>
               </a:rPr>
-              <a:t>SBB Infrastruktur</a:t>
-            </a:r>
-            <a:r>
-              <a:rPr lang="de-DE" sz="1100" i="1" u="sng" dirty="0"/>
-              <a:t>SBB Infrastruktur</a:t>
-            </a:r>
-            <a:r>
-              <a:rPr lang="de-DE" sz="1100" b="1" u="sng" dirty="0">
+              <a:t>Challenge</a:t>
+            </a:r>
+            <a:r>
+              <a:rPr lang="de-DE" sz="1800" i="1" u="sng" dirty="0"/>
+              <a:t> </a:t>
+            </a:r>
+            <a:r>
+              <a:rPr lang="de-DE" sz="1800" b="1" u="sng" dirty="0">
                 <a:solidFill>
                   <a:srgbClr val="FF0000"/>
                 </a:solidFill>
               </a:rPr>
-              <a:t>SBB Infrastruktur</a:t>
-            </a:r>
-          </a:p>
-          <a:p>
-            <a:r>
-              <a:rPr lang="de-DE" sz="1100" i="1" dirty="0"/>
-              <a:t/>
-            </a:r>
-            <a:br>
-              <a:rPr lang="de-DE" sz="1400" i="1" dirty="0"/>
-            </a:br>
-            <a:r>
-              <a:rPr lang="de-DE" sz="1100" i="1" dirty="0"/>
-              <a:t/>
-            </a:r>
+              <a:t>Owner</a:t>
+            </a:r>
+          </a:p>
+          <a:p>
+            <a:r>
+              <a:rPr lang="de-DE" sz="1400" i="1" dirty="0">
+                <a:hlinkClick r:id="rId4"/>
+              </a:rPr>
+              <a:t>Simon.noelle@sbb.ch</a:t>
+            </a:r>
+            <a:endParaRPr lang="de-DE" sz="1400" i="1" dirty="0"/>
+          </a:p>
+          <a:p>
+            <a:r>
+              <a:rPr lang="de-DE" sz="1400" i="1" dirty="0">
+                <a:hlinkClick r:id="rId5"/>
+              </a:rPr>
+              <a:t>Samuel.engel@sbb.ch</a:t>
+            </a:r>
+            <a:endParaRPr lang="de-DE" sz="1400" i="1" dirty="0"/>
           </a:p>
         </p:txBody>
       </p:sp>
     </p:spTree>
     <p:extLst>
       <p:ext uri="{BB962C8B-B14F-4D97-AF65-F5344CB8AC3E}">
-        <p14:creationId xmlns:p14="http://schemas.microsoft.com/office/powerpoint/2010/main" val="3702960545"/>
+        <p14:creationId xmlns:p14="http://schemas.microsoft.com/office/powerpoint/2010/main" val="3161496364"/>
       </p:ext>
     </p:extLst>
   </p:cSld>
@@ -4020,22 +4005,10 @@
               <a:buNone/>
             </a:pPr>
             <a:r>
-              <a:rPr lang="de-DE" sz="1100" dirty="0"/>
+              <a:rPr lang="de-DE" sz="1600" dirty="0"/>
               <a:t>SBB manages 10,000+ infrastructure contracts from 150 years (crossing structures, financing agreements, station contracts). Contracts exist as PDFs – from handwritten documents (1926) to current agreements. Contract data must be manually captured in SAP/ContrAct: 13 fields + cost allocation. This is time-consuming, error-prone, and does not scale.</a:t>
             </a:r>
-            <a:r>
-              <a:rPr lang="de-DE" sz="1050" dirty="0" err="1"/>
-              <a:t/>
-            </a:r>
-            <a:r>
-              <a:rPr lang="de-DE" sz="1050" dirty="0"/>
-              <a:t/>
-            </a:r>
-            <a:r>
-              <a:rPr lang="de-DE" sz="1050" dirty="0" err="1"/>
-              <a:t/>
-            </a:r>
-            <a:endParaRPr lang="de-DE" sz="1050" dirty="0"/>
+            <a:endParaRPr lang="de-DE" sz="1400" dirty="0"/>
           </a:p>
         </p:txBody>
       </p:sp>
@@ -4329,22 +4302,10 @@
               <a:buNone/>
             </a:pPr>
             <a:r>
-              <a:rPr lang="de-DE" sz="1100" dirty="0"/>
+              <a:rPr lang="de-DE" sz="1600" dirty="0"/>
               <a:t>AI-powered extraction pipeline: PDF → text extraction (markitdown) → LLM structured extraction → validated JSON. Each field includes confidence level (eindeutig/abgeleitet/fehlend) and source reference. Validated against a machine-readable contract taxonomy schema.</a:t>
             </a:r>
-            <a:r>
-              <a:rPr lang="de-DE" sz="1050" dirty="0" err="1"/>
-              <a:t/>
-            </a:r>
-            <a:r>
-              <a:rPr lang="de-DE" sz="1050" dirty="0"/>
-              <a:t/>
-            </a:r>
-            <a:r>
-              <a:rPr lang="de-DE" sz="1050" dirty="0" err="1"/>
-              <a:t/>
-            </a:r>
-            <a:endParaRPr lang="de-DE" sz="1050" dirty="0"/>
+            <a:endParaRPr lang="de-DE" sz="1400" dirty="0"/>
           </a:p>
         </p:txBody>
       </p:sp>
@@ -4602,8 +4563,13 @@
           <a:p>
             <a:r>
               <a:rPr lang="de-DE" sz="1100" dirty="0"/>
-              <a:t>GitHub Repository: https://github.com/OpenRail-Playground/A38</a:t>
-            </a:r>
+              <a:t>GitHub Repository: https://github.com/OpenRail-Playground/A38/</a:t>
+            </a:r>
+            <a:r>
+              <a:rPr lang="de-DE" sz="1100" dirty="0" err="1"/>
+              <a:t>aca</a:t>
+            </a:r>
+            <a:endParaRPr lang="de-DE" sz="1100" dirty="0"/>
           </a:p>
           <a:p>
             <a:r>
@@ -4683,21 +4649,12 @@
           </a:bodyPr>
           <a:lstStyle/>
           <a:p>
+            <a:pPr marL="0" indent="0">
+              <a:buNone/>
+            </a:pPr>
             <a:r>
               <a:rPr lang="de-DE" sz="1100" dirty="0"/>
               <a:t>SBB Infrastruktur (contract management), asset managers, finance departments, legal teams. Applicable to DB, OeBB and other railways with similar contract portfolios.</a:t>
-            </a:r>
-            <a:r>
-              <a:rPr lang="de-DE" sz="1050" dirty="0" err="1"/>
-              <a:t/>
-            </a:r>
-            <a:r>
-              <a:rPr lang="de-DE" sz="1050" dirty="0"/>
-              <a:t/>
-            </a:r>
-            <a:r>
-              <a:rPr lang="de-DE" sz="1050" dirty="0" err="1"/>
-              <a:t/>
             </a:r>
             <a:endParaRPr lang="de-DE" sz="1050" dirty="0"/>
           </a:p>
@@ -4969,21 +4926,12 @@
             </a:lvl9pPr>
           </a:lstStyle>
           <a:p>
+            <a:pPr marL="0" indent="0">
+              <a:buNone/>
+            </a:pPr>
             <a:r>
               <a:rPr lang="de-DE" sz="1100" dirty="0"/>
               <a:t>Manual data entry into SAP/ContrAct. No production-grade automated solution exists.</a:t>
-            </a:r>
-            <a:r>
-              <a:rPr lang="de-DE" sz="1050" dirty="0" err="1"/>
-              <a:t/>
-            </a:r>
-            <a:r>
-              <a:rPr lang="de-DE" sz="1050" dirty="0"/>
-              <a:t/>
-            </a:r>
-            <a:r>
-              <a:rPr lang="de-DE" sz="1050" dirty="0" err="1"/>
-              <a:t/>
             </a:r>
             <a:endParaRPr lang="de-DE" sz="1050" dirty="0"/>
           </a:p>
@@ -5255,21 +5203,12 @@
             </a:lvl9pPr>
           </a:lstStyle>
           <a:p>
+            <a:pPr marL="0" indent="0">
+              <a:buNone/>
+            </a:pPr>
             <a:r>
               <a:rPr lang="de-DE" sz="1100" dirty="0"/>
               <a:t>10,000+ contracts x 30-60 min manual effort. Automated extraction reduces to minutes with human-in-the-loop for edge cases. Enables proactive contract management (expiry alerts, missing successors).</a:t>
-            </a:r>
-            <a:r>
-              <a:rPr lang="de-DE" sz="1050" dirty="0" err="1"/>
-              <a:t/>
-            </a:r>
-            <a:r>
-              <a:rPr lang="de-DE" sz="1050" dirty="0"/>
-              <a:t/>
-            </a:r>
-            <a:r>
-              <a:rPr lang="de-DE" sz="1050" dirty="0" err="1"/>
-              <a:t/>
             </a:r>
             <a:endParaRPr lang="de-DE" sz="1050" dirty="0"/>
           </a:p>
@@ -5538,21 +5477,12 @@
             </a:lvl9pPr>
           </a:lstStyle>
           <a:p>
+            <a:pPr marL="0" indent="0">
+              <a:buNone/>
+            </a:pPr>
             <a:r>
               <a:rPr lang="de-DE" sz="1100" dirty="0"/>
               <a:t>Pure OCR without LLM (cannot handle semantic extraction from complex legal text). Unvalidated LLM output without taxonomy schema (not auditable). Fully manual approach (does not scale).</a:t>
-            </a:r>
-            <a:r>
-              <a:rPr lang="de-DE" sz="1050" dirty="0" err="1"/>
-              <a:t/>
-            </a:r>
-            <a:r>
-              <a:rPr lang="de-DE" sz="1050" dirty="0"/>
-              <a:t/>
-            </a:r>
-            <a:r>
-              <a:rPr lang="de-DE" sz="1050" dirty="0" err="1"/>
-              <a:t/>
             </a:r>
             <a:endParaRPr lang="de-DE" sz="1050" dirty="0"/>
           </a:p>
@@ -5830,21 +5760,12 @@
             </a:lvl9pPr>
           </a:lstStyle>
           <a:p>
+            <a:pPr marL="0" indent="0">
+              <a:buNone/>
+            </a:pPr>
             <a:r>
               <a:rPr lang="de-DE" sz="1100" dirty="0"/>
               <a:t>Better contract oversight reduces risk of missed obligations. Enables cross-company contract interoperability. Foundation for automated compliance checking (bridge to OSCAL4Rail).</a:t>
-            </a:r>
-            <a:r>
-              <a:rPr lang="de-DE" sz="1050" dirty="0" err="1"/>
-              <a:t/>
-            </a:r>
-            <a:r>
-              <a:rPr lang="de-DE" sz="1050" dirty="0"/>
-              <a:t/>
-            </a:r>
-            <a:r>
-              <a:rPr lang="de-DE" sz="1050" dirty="0" err="1"/>
-              <a:t/>
             </a:r>
             <a:endParaRPr lang="de-DE" sz="1050" dirty="0"/>
           </a:p>
@@ -6125,21 +6046,12 @@
             </a:lvl9pPr>
           </a:lstStyle>
           <a:p>
+            <a:pPr marL="0" indent="0">
+              <a:buNone/>
+            </a:pPr>
             <a:r>
               <a:rPr lang="de-DE" sz="1100" dirty="0"/>
               <a:t>Older contracts (pre-1990, handwritten) have lower extraction quality. Multi-language support (DE/FR/IT) needs tuning. LLM availability and cost for batch processing. Data privacy for contract parties.</a:t>
-            </a:r>
-            <a:r>
-              <a:rPr lang="de-DE" sz="1050" dirty="0" err="1"/>
-              <a:t/>
-            </a:r>
-            <a:r>
-              <a:rPr lang="de-DE" sz="1050" dirty="0"/>
-              <a:t/>
-            </a:r>
-            <a:r>
-              <a:rPr lang="de-DE" sz="1050" dirty="0" err="1"/>
-              <a:t/>
             </a:r>
             <a:endParaRPr lang="de-DE" sz="1050" dirty="0"/>
           </a:p>
@@ -6420,21 +6332,12 @@
             </a:lvl9pPr>
           </a:lstStyle>
           <a:p>
+            <a:pPr marL="0" indent="0">
+              <a:buNone/>
+            </a:pPr>
             <a:r>
               <a:rPr lang="de-DE" sz="1100" dirty="0"/>
               <a:t>LLM extraction: mature (Claude Sonnet 4). PDF parsing (markitdown): production-ready. JSON Schema validation: standard. Taxonomy model: prototype (Hack4Rail 2026).</a:t>
-            </a:r>
-            <a:r>
-              <a:rPr lang="de-DE" sz="1050" dirty="0" err="1"/>
-              <a:t/>
-            </a:r>
-            <a:r>
-              <a:rPr lang="de-DE" sz="1050" dirty="0"/>
-              <a:t/>
-            </a:r>
-            <a:r>
-              <a:rPr lang="de-DE" sz="1050" dirty="0" err="1"/>
-              <a:t/>
             </a:r>
             <a:endParaRPr lang="de-DE" sz="1050" dirty="0"/>
           </a:p>
@@ -6711,21 +6614,12 @@
             </a:lvl9pPr>
           </a:lstStyle>
           <a:p>
+            <a:pPr marL="0" indent="0">
+              <a:buNone/>
+            </a:pPr>
             <a:r>
               <a:rPr lang="de-DE" sz="1100" dirty="0"/>
               <a:t>May depend on the railway company.</a:t>
-            </a:r>
-            <a:r>
-              <a:rPr lang="de-DE" sz="1050" dirty="0" err="1"/>
-              <a:t/>
-            </a:r>
-            <a:r>
-              <a:rPr lang="de-DE" sz="1050" dirty="0"/>
-              <a:t/>
-            </a:r>
-            <a:r>
-              <a:rPr lang="de-DE" sz="1050" dirty="0" err="1"/>
-              <a:t/>
             </a:r>
             <a:endParaRPr lang="de-DE" sz="1050" dirty="0"/>
           </a:p>
@@ -7136,6 +7030,15 @@
 </file>
 
 <file path=customXml/item1.xml><?xml version="1.0" encoding="utf-8"?>
+<?mso-contentType ?>
+<FormTemplates xmlns="http://schemas.microsoft.com/sharepoint/v3/contenttype/forms">
+  <Display>DocumentLibraryForm</Display>
+  <Edit>DocumentLibraryForm</Edit>
+  <New>DocumentLibraryForm</New>
+</FormTemplates>
+</file>
+
+<file path=customXml/item2.xml><?xml version="1.0" encoding="utf-8"?>
 <p:properties xmlns:p="http://schemas.microsoft.com/office/2006/metadata/properties" xmlns:xsi="http://www.w3.org/2001/XMLSchema-instance" xmlns:pc="http://schemas.microsoft.com/office/infopath/2007/PartnerControls">
   <documentManagement>
     <Copyright xmlns="b106c448-c3d1-41cc-8fd9-3acb307364b4" xsi:nil="true"/>
@@ -7147,7 +7050,7 @@
 </p:properties>
 </file>
 
-<file path=customXml/item2.xml><?xml version="1.0" encoding="utf-8"?>
+<file path=customXml/item3.xml><?xml version="1.0" encoding="utf-8"?>
 <ct:contentTypeSchema xmlns:ct="http://schemas.microsoft.com/office/2006/metadata/contentType" xmlns:ma="http://schemas.microsoft.com/office/2006/metadata/properties/metaAttributes" ct:_="" ma:_="" ma:contentTypeName="Dokument" ma:contentTypeID="0x010100C5895299445B8C4DB378BBB718B1F939" ma:contentTypeVersion="17" ma:contentTypeDescription="Ein neues Dokument erstellen." ma:contentTypeScope="" ma:versionID="efa937a253b8a0ad253458d0295c9a6c">
   <xsd:schema xmlns:xsd="http://www.w3.org/2001/XMLSchema" xmlns:xs="http://www.w3.org/2001/XMLSchema" xmlns:p="http://schemas.microsoft.com/office/2006/metadata/properties" xmlns:ns2="b106c448-c3d1-41cc-8fd9-3acb307364b4" xmlns:ns3="b043894e-b4c8-44d0-9690-d7947297ac19" targetNamespace="http://schemas.microsoft.com/office/2006/metadata/properties" ma:root="true" ma:fieldsID="af1e72e99746a9a12b0b64b9fe407f72" ns2:_="" ns3:_="">
     <xsd:import namespace="b106c448-c3d1-41cc-8fd9-3acb307364b4"/>
@@ -7386,16 +7289,15 @@
 </ct:contentTypeSchema>
 </file>
 
-<file path=customXml/item3.xml><?xml version="1.0" encoding="utf-8"?>
-<?mso-contentType ?>
-<FormTemplates xmlns="http://schemas.microsoft.com/sharepoint/v3/contenttype/forms">
-  <Display>DocumentLibraryForm</Display>
-  <Edit>DocumentLibraryForm</Edit>
-  <New>DocumentLibraryForm</New>
-</FormTemplates>
+<file path=customXml/itemProps1.xml><?xml version="1.0" encoding="utf-8"?>
+<ds:datastoreItem xmlns:ds="http://schemas.openxmlformats.org/officeDocument/2006/customXml" ds:itemID="{5DD488EB-8795-4A31-B76F-16B318CFE1F7}">
+  <ds:schemaRefs>
+    <ds:schemaRef ds:uri="http://schemas.microsoft.com/sharepoint/v3/contenttype/forms"/>
+  </ds:schemaRefs>
+</ds:datastoreItem>
 </file>
 
-<file path=customXml/itemProps1.xml><?xml version="1.0" encoding="utf-8"?>
+<file path=customXml/itemProps2.xml><?xml version="1.0" encoding="utf-8"?>
 <ds:datastoreItem xmlns:ds="http://schemas.openxmlformats.org/officeDocument/2006/customXml" ds:itemID="{BB3B6C51-77D4-4F63-A8EC-8C7A763498FB}">
   <ds:schemaRefs>
     <ds:schemaRef ds:uri="http://schemas.microsoft.com/office/2006/metadata/properties"/>
@@ -7406,7 +7308,7 @@
 </ds:datastoreItem>
 </file>
 
-<file path=customXml/itemProps2.xml><?xml version="1.0" encoding="utf-8"?>
+<file path=customXml/itemProps3.xml><?xml version="1.0" encoding="utf-8"?>
 <ds:datastoreItem xmlns:ds="http://schemas.openxmlformats.org/officeDocument/2006/customXml" ds:itemID="{B4D14693-25A4-4C1A-ABDC-E6E0CFF1A69C}">
   <ds:schemaRefs>
     <ds:schemaRef ds:uri="http://schemas.microsoft.com/office/2006/metadata/contentType"/>
@@ -7425,14 +7327,6 @@
 </ds:datastoreItem>
 </file>
 
-<file path=customXml/itemProps3.xml><?xml version="1.0" encoding="utf-8"?>
-<ds:datastoreItem xmlns:ds="http://schemas.openxmlformats.org/officeDocument/2006/customXml" ds:itemID="{5DD488EB-8795-4A31-B76F-16B318CFE1F7}">
-  <ds:schemaRefs>
-    <ds:schemaRef ds:uri="http://schemas.microsoft.com/sharepoint/v3/contenttype/forms"/>
-  </ds:schemaRefs>
-</ds:datastoreItem>
-</file>
-
 <file path=docMetadata/LabelInfo.xml><?xml version="1.0" encoding="utf-8"?>
 <clbl:labelList xmlns:clbl="http://schemas.microsoft.com/office/2020/mipLabelMetadata">
   <clbl:label id="{0cda0c22-3e77-43b9-8faf-0bad2baf7893}" enabled="1" method="Standard" siteId="{085c0b65-6a84-4006-851e-5faa7ec5367e}" contentBits="2" removed="0"/>

</xml_diff>